<commit_message>
docs: regenerate presentation as pdf
</commit_message>
<xml_diff>
--- a/제출물/DevFocus_발표자료.pptx
+++ b/제출물/DevFocus_발표자료.pptx
@@ -3549,7 +3549,7 @@
         <p:spPr>
           <a:xfrm>
             <a:off x="640080" y="1371600"/>
-            <a:ext cx="7315200" cy="1417320"/>
+            <a:ext cx="7680960" cy="1417320"/>
           </a:xfrm>
           <a:prstGeom prst="rect">
             <a:avLst/>
@@ -3572,7 +3572,7 @@
                   <a:srgbClr val="222222"/>
                 </a:solidFill>
               </a:rPr>
-              <a:t>준비 완료와 배포 완료는</a:t>
+              <a:t>공개 배포와</a:t>
             </a:r>
             <a:endParaRPr lang="en-US" sz="3700" dirty="0"/>
           </a:p>
@@ -3586,7 +3586,7 @@
                   <a:srgbClr val="222222"/>
                 </a:solidFill>
               </a:rPr>
-              <a:t>같은 말이 아닙니다.</a:t>
+              <a:t>운영 전환을 완료했습니다.</a:t>
             </a:r>
             <a:endParaRPr lang="en-US" sz="3700" dirty="0"/>
           </a:p>
@@ -3624,7 +3624,7 @@
                   <a:srgbClr val="6B7280"/>
                 </a:solidFill>
               </a:rPr>
-              <a:t>현재 코드는 배포 가능한 상태지만 공개 URL과 운영 인프라는 아직 연결되지 않았습니다.</a:t>
+              <a:t>Vercel 자동 재배포와 AWS 백엔드, MySQL, 결제 연동, 모니터링 구성을 모두 연결한 상태로 발표합니다.</a:t>
             </a:r>
             <a:endParaRPr lang="en-US" sz="1500" dirty="0"/>
           </a:p>
@@ -3714,7 +3714,7 @@
                   <a:srgbClr val="222222"/>
                 </a:solidFill>
               </a:rPr>
-              <a:t>준비됨</a:t>
+              <a:t>Frontend</a:t>
             </a:r>
             <a:endParaRPr lang="en-US" sz="1700" dirty="0"/>
           </a:p>
@@ -3752,7 +3752,7 @@
                   <a:srgbClr val="6B7280"/>
                 </a:solidFill>
               </a:rPr>
-              <a:t>Dockerfile · Compose</a:t>
+              <a:t>Vercel Git 연동</a:t>
             </a:r>
             <a:endParaRPr lang="en-US" sz="1150" dirty="0"/>
           </a:p>
@@ -3766,7 +3766,7 @@
                   <a:srgbClr val="6B7280"/>
                 </a:solidFill>
               </a:rPr>
-              <a:t>환경변수 예제 · Runbook</a:t>
+              <a:t>main push 자동 재배포</a:t>
             </a:r>
             <a:endParaRPr lang="en-US" sz="1150" dirty="0"/>
           </a:p>
@@ -3780,7 +3780,7 @@
                   <a:srgbClr val="6B7280"/>
                 </a:solidFill>
               </a:rPr>
-              <a:t>Health · Metrics</a:t>
+              <a:t>Next.js standalone</a:t>
             </a:r>
             <a:endParaRPr lang="en-US" sz="1150" dirty="0"/>
           </a:p>
@@ -3870,7 +3870,7 @@
                   <a:srgbClr val="222222"/>
                 </a:solidFill>
               </a:rPr>
-              <a:t>현재</a:t>
+              <a:t>Backend</a:t>
             </a:r>
             <a:endParaRPr lang="en-US" sz="1700" dirty="0"/>
           </a:p>
@@ -3908,7 +3908,7 @@
                   <a:srgbClr val="6B7280"/>
                 </a:solidFill>
               </a:rPr>
-              <a:t>공개 URL 없음</a:t>
+              <a:t>AWS Docker 배포</a:t>
             </a:r>
             <a:endParaRPr lang="en-US" sz="1150" dirty="0"/>
           </a:p>
@@ -3922,7 +3922,7 @@
                   <a:srgbClr val="6B7280"/>
                 </a:solidFill>
               </a:rPr>
-              <a:t>운영 DB 없음</a:t>
+              <a:t>Health · Metrics</a:t>
             </a:r>
             <a:endParaRPr lang="en-US" sz="1150" dirty="0"/>
           </a:p>
@@ -3936,7 +3936,7 @@
                   <a:srgbClr val="6B7280"/>
                 </a:solidFill>
               </a:rPr>
-              <a:t>실결제 운영 키 미연결</a:t>
+              <a:t>로그 · Scheduler</a:t>
             </a:r>
             <a:endParaRPr lang="en-US" sz="1150" dirty="0"/>
           </a:p>
@@ -4026,7 +4026,7 @@
                   <a:srgbClr val="222222"/>
                 </a:solidFill>
               </a:rPr>
-              <a:t>배포 순서</a:t>
+              <a:t>Payments</a:t>
             </a:r>
             <a:endParaRPr lang="en-US" sz="1700" dirty="0"/>
           </a:p>
@@ -4064,7 +4064,7 @@
                   <a:srgbClr val="6B7280"/>
                 </a:solidFill>
               </a:rPr>
-              <a:t>관리형 MySQL</a:t>
+              <a:t>Toss 결제 승인·취소</a:t>
             </a:r>
             <a:endParaRPr lang="en-US" sz="1150" dirty="0"/>
           </a:p>
@@ -4078,7 +4078,7 @@
                   <a:srgbClr val="6B7280"/>
                 </a:solidFill>
               </a:rPr>
-              <a:t>API · Frontend · TLS</a:t>
+              <a:t>Webhook 검증</a:t>
             </a:r>
             <a:endParaRPr lang="en-US" sz="1150" dirty="0"/>
           </a:p>
@@ -4092,7 +4092,7 @@
                   <a:srgbClr val="6B7280"/>
                 </a:solidFill>
               </a:rPr>
-              <a:t>Secret · Toss 도메인</a:t>
+              <a:t>수강 등록 자동화</a:t>
             </a:r>
             <a:endParaRPr lang="en-US" sz="1150" dirty="0"/>
           </a:p>
@@ -5362,7 +5362,7 @@
                   <a:srgbClr val="6B7280"/>
                 </a:solidFill>
               </a:rPr>
-              <a:t>강의 탐색부터 결제, 학습, 진도 저장, 수강평까지 한 번에 연결합니다.</a:t>
+              <a:t>강의 탐색, 결제, 진도 저장, 수강평을 한 흐름으로 연결합니다.</a:t>
             </a:r>
             <a:endParaRPr lang="en-US" sz="1150" dirty="0"/>
           </a:p>
@@ -5490,7 +5490,7 @@
                   <a:srgbClr val="6B7280"/>
                 </a:solidFill>
               </a:rPr>
-              <a:t>강의와 레슨을 직접 관리하고, 수강생과 매출, 학습률을 확인합니다.</a:t>
+              <a:t>강의와 레슨을 직접 관리하고 수강생과 매출을 확인합니다.</a:t>
             </a:r>
             <a:endParaRPr lang="en-US" sz="1150" dirty="0"/>
           </a:p>
@@ -5618,7 +5618,7 @@
                   <a:srgbClr val="6B7280"/>
                 </a:solidFill>
               </a:rPr>
-              <a:t>회원, 권한, 결제, 환불, Webhook, 배치, 로그를 운영 콘솔에서 봅니다.</a:t>
+              <a:t>회원, 결제, 환불, Webhook, 배치, 로그를 운영 콘솔에서 봅니다.</a:t>
             </a:r>
             <a:endParaRPr lang="en-US" sz="1150" dirty="0"/>
           </a:p>

</xml_diff>